<commit_message>
Kit 8: universal lab-exemplar retrofit (owner directive)
Ms. Rivera builds one culture page through all four lab steps: five
norms, the win-fail-steal routine with date and owner, onboarding owner
plus skeptic partners, the semester strip. Large exemplar cards on
slides 19-22, chips and script rivera-lines aligned, teaching content
and timings unchanged. Rebuilt and visually verified per KIT_STANDARD.

Co-Authored-By: Claude Fable 5 <noreply@anthropic.com>
Claude-Session: https://claude.ai/code/session_019agQ42s1igQaB2X7GGat9R
</commit_message>
<xml_diff>
--- a/kits/kit08/Kit08_PresentationDeck.pptx
+++ b/kits/kit08/Kit08_PresentationDeck.pptx
@@ -1323,7 +1323,7 @@
           <a:p>
             <a:r>
               <a:rPr lang="en-US" dirty="0"/>
-              <a:t>Dark slide. Groups of 3-4 (not pairs), mixed departments. Devices optional; this lab drafts text.</a:t>
+              <a:t>Dark slide. Groups of 3-4 (not pairs), mixed departments. Devices optional; this lab drafts text. Ms. Rivera drafts ONE culture page across all four steps: norms, routine, onboarding, semester strip, one page. Her page appears large on every step slide, so anyone lost can copy her structure.</a:t>
             </a:r>
             <a:endParaRPr lang="en-US" dirty="0"/>
           </a:p>
@@ -1411,7 +1411,7 @@
           <a:p>
             <a:r>
               <a:rPr lang="en-US" dirty="0"/>
-              <a:t>7 protected minutes. Circulate; push for the building's own words, not policy-speak.</a:t>
+              <a:t>7 protected minutes. Circulate; push for the building's own words, not policy-speak. Rivera's culture page is the running exemplar for the whole lab; this card is its top half, five norms in her building's voice. Anyone stuck can copy her structure and swap in their own words.</a:t>
             </a:r>
             <a:endParaRPr lang="en-US" dirty="0"/>
           </a:p>
@@ -1587,7 +1587,7 @@
           <a:p>
             <a:r>
               <a:rPr lang="en-US" dirty="0"/>
-              <a:t>4 minutes. A routine without a date and an owner is a wish; insist on both.</a:t>
+              <a:t>4 minutes. A routine without a date and an owner is a wish; insist on both. Rivera's card is the same culture page gaining its routine line: rhythm picked, five minutes, round one dated and owned.</a:t>
             </a:r>
             <a:endParaRPr lang="en-US" dirty="0"/>
           </a:p>
@@ -1675,7 +1675,7 @@
           <a:p>
             <a:r>
               <a:rPr lang="en-US" dirty="0"/>
-              <a:t>4 minutes. 45-min cut: fold into step 4's block. Recruiting skeptics respectfully is the culture's best quality-control hire.</a:t>
+              <a:t>4 minutes. 45-min cut: fold into step 4's block. Rivera's page now carries its onboarding owner and its skeptic partners; recruiting skeptics respectfully is the culture's best quality-control hire.</a:t>
             </a:r>
             <a:endParaRPr lang="en-US" dirty="0"/>
           </a:p>
@@ -1763,7 +1763,7 @@
           <a:p>
             <a:r>
               <a:rPr lang="en-US" dirty="0"/>
-              <a:t>4 minutes. The 30-day plans are the refresher material; nothing new to write, just dates to claim.</a:t>
+              <a:t>4 minutes. The 30-day plans are the refresher material; nothing new to write, just dates to claim. Rivera's page finishes with its semester strip: months and kit numbers, one line each. That completes her one-page culture draft.</a:t>
             </a:r>
             <a:endParaRPr lang="en-US" dirty="0"/>
           </a:p>
@@ -9553,7 +9553,7 @@
                 <a:ea typeface="Inter" pitchFamily="34" charset="-122"/>
                 <a:cs typeface="Inter" pitchFamily="34" charset="-120"/>
               </a:rPr>
-              <a:t>Her lab: norms, routine, onboarding, calendar. The culture, drafted.</a:t>
+              <a:t>Her lab pick, one page all the way through: her school's culture page.</a:t>
             </a:r>
             <a:endParaRPr lang="en-US" sz="1000" dirty="0"/>
           </a:p>
@@ -10334,7 +10334,7 @@
                 <a:ea typeface="Inter" pitchFamily="34" charset="-122"/>
                 <a:cs typeface="Inter" pitchFamily="34" charset="-120"/>
               </a:rPr>
-              <a:t>On her screen: the five norms, drafted with her partner.</a:t>
+              <a:t>Her culture page, step 1: the five norms, in her building's words.</a:t>
             </a:r>
             <a:endParaRPr lang="en-US" sz="1000" dirty="0"/>
           </a:p>
@@ -10388,7 +10388,7 @@
         <p:spPr>
           <a:xfrm>
             <a:off x="548640" y="384048"/>
-            <a:ext cx="11091672" cy="777240"/>
+            <a:ext cx="7955280" cy="777240"/>
           </a:xfrm>
           <a:prstGeom prst="rect">
             <a:avLst/>
@@ -10426,8 +10426,8 @@
         </p:nvSpPr>
         <p:spPr>
           <a:xfrm>
-            <a:off x="640080" y="1371600"/>
-            <a:ext cx="10908792" cy="4297680"/>
+            <a:off x="640080" y="1554480"/>
+            <a:ext cx="5394960" cy="4023360"/>
           </a:xfrm>
           <a:prstGeom prst="rect">
             <a:avLst/>
@@ -10447,7 +10447,7 @@
               <a:buChar char="•"/>
             </a:pPr>
             <a:r>
-              <a:rPr lang="en-US" sz="2100" dirty="0">
+              <a:rPr lang="en-US" sz="1600" dirty="0">
                 <a:solidFill>
                   <a:srgbClr val="1B1F24"/>
                 </a:solidFill>
@@ -10457,7 +10457,7 @@
               </a:rPr>
               <a:t>The five jobs are fixed: privacy · review · honesty · sharing · the protected list</a:t>
             </a:r>
-            <a:endParaRPr lang="en-US" sz="2100" dirty="0"/>
+            <a:endParaRPr lang="en-US" sz="1600" dirty="0"/>
           </a:p>
           <a:p>
             <a:pPr marL="342900" indent="-342900">
@@ -10468,7 +10468,7 @@
               <a:buChar char="•"/>
             </a:pPr>
             <a:r>
-              <a:rPr lang="en-US" sz="2100" dirty="0">
+              <a:rPr lang="en-US" sz="1600" dirty="0">
                 <a:solidFill>
                   <a:srgbClr val="1B1F24"/>
                 </a:solidFill>
@@ -10478,7 +10478,7 @@
               </a:rPr>
               <a:t>The wording is yours: "we never put a student into a chatbot" beats any compliance sentence</a:t>
             </a:r>
-            <a:endParaRPr lang="en-US" sz="2100" dirty="0"/>
+            <a:endParaRPr lang="en-US" sz="1600" dirty="0"/>
           </a:p>
           <a:p>
             <a:pPr marL="342900" indent="-342900">
@@ -10489,7 +10489,7 @@
               <a:buChar char="•"/>
             </a:pPr>
             <a:r>
-              <a:rPr lang="en-US" sz="2100" dirty="0">
+              <a:rPr lang="en-US" sz="1600" dirty="0">
                 <a:solidFill>
                   <a:srgbClr val="1B1F24"/>
                 </a:solidFill>
@@ -10499,7 +10499,7 @@
               </a:rPr>
               <a:t>One line per norm</a:t>
             </a:r>
-            <a:endParaRPr lang="en-US" sz="2100" dirty="0"/>
+            <a:endParaRPr lang="en-US" sz="1600" dirty="0"/>
           </a:p>
           <a:p>
             <a:pPr marL="342900" indent="-342900">
@@ -10510,7 +10510,7 @@
               <a:buChar char="•"/>
             </a:pPr>
             <a:r>
-              <a:rPr lang="en-US" sz="2100" b="1" dirty="0">
+              <a:rPr lang="en-US" sz="1600" b="1" dirty="0">
                 <a:solidFill>
                   <a:srgbClr val="1B1F24"/>
                 </a:solidFill>
@@ -10520,7 +10520,290 @@
               </a:rPr>
               <a:t>Finished early? Argue about the wording. That argument is the culture forming.</a:t>
             </a:r>
-            <a:endParaRPr lang="en-US" sz="2100" dirty="0"/>
+            <a:endParaRPr lang="en-US" sz="1600" dirty="0"/>
+          </a:p>
+        </p:txBody>
+      </p:sp>
+      <p:sp>
+        <p:nvSpPr>
+          <p:cNvPr id="15" name="Shape 12"/>
+          <p:cNvSpPr/>
+          <p:nvPr/>
+        </p:nvSpPr>
+        <p:spPr>
+          <a:xfrm>
+            <a:off x="6263640" y="1554480"/>
+            <a:ext cx="5394960" cy="4023360"/>
+          </a:xfrm>
+          <a:prstGeom prst="roundRect">
+            <a:avLst>
+              <a:gd name="adj" fmla="val 2045"/>
+            </a:avLst>
+          </a:prstGeom>
+          <a:solidFill>
+            <a:srgbClr val="EAF5F3"/>
+          </a:solidFill>
+          <a:ln w="12700">
+            <a:solidFill>
+              <a:srgbClr val="EAF5F3"/>
+            </a:solidFill>
+            <a:prstDash val="solid"/>
+          </a:ln>
+        </p:spPr>
+      </p:sp>
+      <p:sp>
+        <p:nvSpPr>
+          <p:cNvPr id="16" name="Text 13"/>
+          <p:cNvSpPr/>
+          <p:nvPr/>
+        </p:nvSpPr>
+        <p:spPr>
+          <a:xfrm>
+            <a:off x="6537960" y="1737360"/>
+            <a:ext cx="4937760" cy="292608"/>
+          </a:xfrm>
+          <a:prstGeom prst="rect">
+            <a:avLst/>
+          </a:prstGeom>
+          <a:noFill/>
+          <a:ln/>
+        </p:spPr>
+        <p:txBody>
+          <a:bodyPr wrap="square" lIns="0" tIns="0" rIns="0" bIns="0" rtlCol="0" anchor="ctr"/>
+          <a:lstStyle/>
+          <a:p>
+            <a:pPr indent="0" marL="0">
+              <a:buNone/>
+            </a:pPr>
+            <a:r>
+              <a:rPr lang="en-US" sz="1250" b="1" spc="150" kern="0" dirty="0">
+                <a:solidFill>
+                  <a:srgbClr val="2A9D8F"/>
+                </a:solidFill>
+                <a:latin typeface="Inter" pitchFamily="34" charset="0"/>
+                <a:ea typeface="Inter" pitchFamily="34" charset="-122"/>
+                <a:cs typeface="Inter" pitchFamily="34" charset="-120"/>
+              </a:rPr>
+              <a:t>MS. RIVERA'S CULTURE PAGE · STEP 1</a:t>
+            </a:r>
+            <a:endParaRPr lang="en-US" sz="1250" dirty="0"/>
+          </a:p>
+        </p:txBody>
+      </p:sp>
+      <p:sp>
+        <p:nvSpPr>
+          <p:cNvPr id="17" name="Text 14"/>
+          <p:cNvSpPr/>
+          <p:nvPr/>
+        </p:nvSpPr>
+        <p:spPr>
+          <a:xfrm>
+            <a:off x="6537960" y="2148840"/>
+            <a:ext cx="4892040" cy="3291840"/>
+          </a:xfrm>
+          <a:prstGeom prst="rect">
+            <a:avLst/>
+          </a:prstGeom>
+          <a:noFill/>
+          <a:ln/>
+        </p:spPr>
+        <p:txBody>
+          <a:bodyPr wrap="square" lIns="0" tIns="0" rIns="0" bIns="0" rtlCol="0" anchor="t"/>
+          <a:lstStyle/>
+          <a:p>
+            <a:pPr indent="0" marL="0">
+              <a:lnSpc>
+                <a:spcPct val="130000"/>
+              </a:lnSpc>
+              <a:buNone/>
+            </a:pPr>
+            <a:r>
+              <a:rPr lang="en-US" sz="1800" b="1" dirty="0">
+                <a:solidFill>
+                  <a:srgbClr val="13293D"/>
+                </a:solidFill>
+                <a:latin typeface="Inter" pitchFamily="34" charset="0"/>
+                <a:ea typeface="Inter" pitchFamily="34" charset="-122"/>
+                <a:cs typeface="Inter" pitchFamily="34" charset="-120"/>
+              </a:rPr>
+              <a:t>Privacy: </a:t>
+            </a:r>
+            <a:pPr indent="0" marL="0">
+              <a:lnSpc>
+                <a:spcPct val="130000"/>
+              </a:lnSpc>
+              <a:buNone/>
+            </a:pPr>
+            <a:r>
+              <a:rPr lang="en-US" sz="1800" dirty="0">
+                <a:solidFill>
+                  <a:srgbClr val="1B1F24"/>
+                </a:solidFill>
+                <a:latin typeface="Inter" pitchFamily="34" charset="0"/>
+                <a:ea typeface="Inter" pitchFamily="34" charset="-122"/>
+                <a:cs typeface="Inter" pitchFamily="34" charset="-120"/>
+              </a:rPr>
+              <a:t>no student in a chatbot. Ever.
+</a:t>
+            </a:r>
+            <a:pPr indent="0" marL="0">
+              <a:lnSpc>
+                <a:spcPct val="130000"/>
+              </a:lnSpc>
+              <a:buNone/>
+            </a:pPr>
+            <a:r>
+              <a:rPr lang="en-US" sz="1800" b="1" dirty="0">
+                <a:solidFill>
+                  <a:srgbClr val="13293D"/>
+                </a:solidFill>
+                <a:latin typeface="Inter" pitchFamily="34" charset="0"/>
+                <a:ea typeface="Inter" pitchFamily="34" charset="-122"/>
+                <a:cs typeface="Inter" pitchFamily="34" charset="-120"/>
+              </a:rPr>
+              <a:t>Review: </a:t>
+            </a:r>
+            <a:pPr indent="0" marL="0">
+              <a:lnSpc>
+                <a:spcPct val="130000"/>
+              </a:lnSpc>
+              <a:buNone/>
+            </a:pPr>
+            <a:r>
+              <a:rPr lang="en-US" sz="1800" dirty="0">
+                <a:solidFill>
+                  <a:srgbClr val="1B1F24"/>
+                </a:solidFill>
+                <a:latin typeface="Inter" pitchFamily="34" charset="0"/>
+                <a:ea typeface="Inter" pitchFamily="34" charset="-122"/>
+                <a:cs typeface="Inter" pitchFamily="34" charset="-120"/>
+              </a:rPr>
+              <a:t>nothing ships unread.
+</a:t>
+            </a:r>
+            <a:pPr indent="0" marL="0">
+              <a:lnSpc>
+                <a:spcPct val="130000"/>
+              </a:lnSpc>
+              <a:buNone/>
+            </a:pPr>
+            <a:r>
+              <a:rPr lang="en-US" sz="1800" b="1" dirty="0">
+                <a:solidFill>
+                  <a:srgbClr val="13293D"/>
+                </a:solidFill>
+                <a:latin typeface="Inter" pitchFamily="34" charset="0"/>
+                <a:ea typeface="Inter" pitchFamily="34" charset="-122"/>
+                <a:cs typeface="Inter" pitchFamily="34" charset="-120"/>
+              </a:rPr>
+              <a:t>Honesty: </a:t>
+            </a:r>
+            <a:pPr indent="0" marL="0">
+              <a:lnSpc>
+                <a:spcPct val="130000"/>
+              </a:lnSpc>
+              <a:buNone/>
+            </a:pPr>
+            <a:r>
+              <a:rPr lang="en-US" sz="1800" dirty="0">
+                <a:solidFill>
+                  <a:srgbClr val="1B1F24"/>
+                </a:solidFill>
+                <a:latin typeface="Inter" pitchFamily="34" charset="0"/>
+                <a:ea typeface="Inter" pitchFamily="34" charset="-122"/>
+                <a:cs typeface="Inter" pitchFamily="34" charset="-120"/>
+              </a:rPr>
+              <a:t>we say what we use.
+</a:t>
+            </a:r>
+            <a:pPr indent="0" marL="0">
+              <a:lnSpc>
+                <a:spcPct val="130000"/>
+              </a:lnSpc>
+              <a:buNone/>
+            </a:pPr>
+            <a:r>
+              <a:rPr lang="en-US" sz="1800" b="1" dirty="0">
+                <a:solidFill>
+                  <a:srgbClr val="13293D"/>
+                </a:solidFill>
+                <a:latin typeface="Inter" pitchFamily="34" charset="0"/>
+                <a:ea typeface="Inter" pitchFamily="34" charset="-122"/>
+                <a:cs typeface="Inter" pitchFamily="34" charset="-120"/>
+              </a:rPr>
+              <a:t>Sharing: </a:t>
+            </a:r>
+            <a:pPr indent="0" marL="0">
+              <a:lnSpc>
+                <a:spcPct val="130000"/>
+              </a:lnSpc>
+              <a:buNone/>
+            </a:pPr>
+            <a:r>
+              <a:rPr lang="en-US" sz="1800" dirty="0">
+                <a:solidFill>
+                  <a:srgbClr val="1B1F24"/>
+                </a:solidFill>
+                <a:latin typeface="Inter" pitchFamily="34" charset="0"/>
+                <a:ea typeface="Inter" pitchFamily="34" charset="-122"/>
+                <a:cs typeface="Inter" pitchFamily="34" charset="-120"/>
+              </a:rPr>
+              <a:t>into the doc, same week.
+</a:t>
+            </a:r>
+            <a:pPr indent="0" marL="0">
+              <a:lnSpc>
+                <a:spcPct val="130000"/>
+              </a:lnSpc>
+              <a:buNone/>
+            </a:pPr>
+            <a:r>
+              <a:rPr lang="en-US" sz="1800" b="1" dirty="0">
+                <a:solidFill>
+                  <a:srgbClr val="13293D"/>
+                </a:solidFill>
+                <a:latin typeface="Inter" pitchFamily="34" charset="0"/>
+                <a:ea typeface="Inter" pitchFamily="34" charset="-122"/>
+                <a:cs typeface="Inter" pitchFamily="34" charset="-120"/>
+              </a:rPr>
+              <a:t>Protected: </a:t>
+            </a:r>
+            <a:pPr indent="0" marL="0">
+              <a:lnSpc>
+                <a:spcPct val="130000"/>
+              </a:lnSpc>
+              <a:buNone/>
+            </a:pPr>
+            <a:r>
+              <a:rPr lang="en-US" sz="1800" dirty="0">
+                <a:solidFill>
+                  <a:srgbClr val="1B1F24"/>
+                </a:solidFill>
+                <a:latin typeface="Inter" pitchFamily="34" charset="0"/>
+                <a:ea typeface="Inter" pitchFamily="34" charset="-122"/>
+                <a:cs typeface="Inter" pitchFamily="34" charset="-120"/>
+              </a:rPr>
+              <a:t>people work stays people.
+</a:t>
+            </a:r>
+            <a:pPr indent="0" marL="0">
+              <a:lnSpc>
+                <a:spcPct val="130000"/>
+              </a:lnSpc>
+              <a:buNone/>
+            </a:pPr>
+            <a:r>
+              <a:rPr lang="en-US" sz="1800" i="1" dirty="0">
+                <a:solidFill>
+                  <a:srgbClr val="5B6B7A"/>
+                </a:solidFill>
+                <a:latin typeface="Inter" pitchFamily="34" charset="0"/>
+                <a:ea typeface="Inter" pitchFamily="34" charset="-122"/>
+                <a:cs typeface="Inter" pitchFamily="34" charset="-120"/>
+              </a:rPr>
+              <a:t>"Sounds like us, not like a policy."</a:t>
+            </a:r>
+            <a:endParaRPr lang="en-US" sz="1800" dirty="0"/>
           </a:p>
         </p:txBody>
       </p:sp>
@@ -11765,7 +12048,7 @@
                 <a:ea typeface="Inter" pitchFamily="34" charset="-122"/>
                 <a:cs typeface="Inter" pitchFamily="34" charset="-120"/>
               </a:rPr>
-              <a:t>Her routine, picked and calendared: five minutes, every other PLC.</a:t>
+              <a:t>Her culture page, step 2: win-fail-steal calendared, round one owned.</a:t>
             </a:r>
             <a:endParaRPr lang="en-US" sz="1000" dirty="0"/>
           </a:p>
@@ -11819,7 +12102,7 @@
         <p:spPr>
           <a:xfrm>
             <a:off x="548640" y="384048"/>
-            <a:ext cx="11091672" cy="777240"/>
+            <a:ext cx="7955280" cy="777240"/>
           </a:xfrm>
           <a:prstGeom prst="rect">
             <a:avLst/>
@@ -11857,8 +12140,8 @@
         </p:nvSpPr>
         <p:spPr>
           <a:xfrm>
-            <a:off x="640080" y="1371600"/>
-            <a:ext cx="10908792" cy="4297680"/>
+            <a:off x="640080" y="1554480"/>
+            <a:ext cx="5394960" cy="4023360"/>
           </a:xfrm>
           <a:prstGeom prst="rect">
             <a:avLst/>
@@ -11878,7 +12161,7 @@
               <a:buChar char="•"/>
             </a:pPr>
             <a:r>
-              <a:rPr lang="en-US" sz="2100" dirty="0">
+              <a:rPr lang="en-US" sz="1700" dirty="0">
                 <a:solidFill>
                   <a:srgbClr val="1B1F24"/>
                 </a:solidFill>
@@ -11888,7 +12171,7 @@
               </a:rPr>
               <a:t>Pick the rhythm this building will actually keep: every PLC, every other, or monthly at staff meetings</a:t>
             </a:r>
-            <a:endParaRPr lang="en-US" sz="2100" dirty="0"/>
+            <a:endParaRPr lang="en-US" sz="1700" dirty="0"/>
           </a:p>
           <a:p>
             <a:pPr marL="342900" indent="-342900">
@@ -11899,7 +12182,7 @@
               <a:buChar char="•"/>
             </a:pPr>
             <a:r>
-              <a:rPr lang="en-US" sz="2100" dirty="0">
+              <a:rPr lang="en-US" sz="1700" dirty="0">
                 <a:solidFill>
                   <a:srgbClr val="1B1F24"/>
                 </a:solidFill>
@@ -11909,7 +12192,7 @@
               </a:rPr>
               <a:t>Win · fail · steal, five minutes</a:t>
             </a:r>
-            <a:endParaRPr lang="en-US" sz="2100" dirty="0"/>
+            <a:endParaRPr lang="en-US" sz="1700" dirty="0"/>
           </a:p>
           <a:p>
             <a:pPr marL="342900" indent="-342900">
@@ -11920,7 +12203,7 @@
               <a:buChar char="•"/>
             </a:pPr>
             <a:r>
-              <a:rPr lang="en-US" sz="2100" b="1" dirty="0">
+              <a:rPr lang="en-US" sz="1700" b="1" dirty="0">
                 <a:solidFill>
                   <a:srgbClr val="1B1F24"/>
                 </a:solidFill>
@@ -11930,7 +12213,155 @@
               </a:rPr>
               <a:t>It counts when it has a date and an owner: who runs round one, and when. Write both.</a:t>
             </a:r>
-            <a:endParaRPr lang="en-US" sz="2100" dirty="0"/>
+            <a:endParaRPr lang="en-US" sz="1700" dirty="0"/>
+          </a:p>
+        </p:txBody>
+      </p:sp>
+      <p:sp>
+        <p:nvSpPr>
+          <p:cNvPr id="15" name="Shape 12"/>
+          <p:cNvSpPr/>
+          <p:nvPr/>
+        </p:nvSpPr>
+        <p:spPr>
+          <a:xfrm>
+            <a:off x="6263640" y="1554480"/>
+            <a:ext cx="5394960" cy="3108960"/>
+          </a:xfrm>
+          <a:prstGeom prst="roundRect">
+            <a:avLst>
+              <a:gd name="adj" fmla="val 2647"/>
+            </a:avLst>
+          </a:prstGeom>
+          <a:solidFill>
+            <a:srgbClr val="EAF5F3"/>
+          </a:solidFill>
+          <a:ln w="12700">
+            <a:solidFill>
+              <a:srgbClr val="EAF5F3"/>
+            </a:solidFill>
+            <a:prstDash val="solid"/>
+          </a:ln>
+        </p:spPr>
+      </p:sp>
+      <p:sp>
+        <p:nvSpPr>
+          <p:cNvPr id="16" name="Text 13"/>
+          <p:cNvSpPr/>
+          <p:nvPr/>
+        </p:nvSpPr>
+        <p:spPr>
+          <a:xfrm>
+            <a:off x="6537960" y="1737360"/>
+            <a:ext cx="4937760" cy="292608"/>
+          </a:xfrm>
+          <a:prstGeom prst="rect">
+            <a:avLst/>
+          </a:prstGeom>
+          <a:noFill/>
+          <a:ln/>
+        </p:spPr>
+        <p:txBody>
+          <a:bodyPr wrap="square" lIns="0" tIns="0" rIns="0" bIns="0" rtlCol="0" anchor="ctr"/>
+          <a:lstStyle/>
+          <a:p>
+            <a:pPr indent="0" marL="0">
+              <a:buNone/>
+            </a:pPr>
+            <a:r>
+              <a:rPr lang="en-US" sz="1250" b="1" spc="150" kern="0" dirty="0">
+                <a:solidFill>
+                  <a:srgbClr val="2A9D8F"/>
+                </a:solidFill>
+                <a:latin typeface="Inter" pitchFamily="34" charset="0"/>
+                <a:ea typeface="Inter" pitchFamily="34" charset="-122"/>
+                <a:cs typeface="Inter" pitchFamily="34" charset="-120"/>
+              </a:rPr>
+              <a:t>MS. RIVERA'S CULTURE PAGE · STEP 2</a:t>
+            </a:r>
+            <a:endParaRPr lang="en-US" sz="1250" dirty="0"/>
+          </a:p>
+        </p:txBody>
+      </p:sp>
+      <p:sp>
+        <p:nvSpPr>
+          <p:cNvPr id="17" name="Text 14"/>
+          <p:cNvSpPr/>
+          <p:nvPr/>
+        </p:nvSpPr>
+        <p:spPr>
+          <a:xfrm>
+            <a:off x="6537960" y="2148840"/>
+            <a:ext cx="4892040" cy="2331720"/>
+          </a:xfrm>
+          <a:prstGeom prst="rect">
+            <a:avLst/>
+          </a:prstGeom>
+          <a:noFill/>
+          <a:ln/>
+        </p:spPr>
+        <p:txBody>
+          <a:bodyPr wrap="square" lIns="0" tIns="0" rIns="0" bIns="0" rtlCol="0" anchor="t"/>
+          <a:lstStyle/>
+          <a:p>
+            <a:pPr indent="0" marL="0">
+              <a:lnSpc>
+                <a:spcPct val="125000"/>
+              </a:lnSpc>
+              <a:buNone/>
+            </a:pPr>
+            <a:r>
+              <a:rPr lang="en-US" sz="2200" b="1" dirty="0">
+                <a:solidFill>
+                  <a:srgbClr val="13293D"/>
+                </a:solidFill>
+                <a:latin typeface="Inter" pitchFamily="34" charset="0"/>
+                <a:ea typeface="Inter" pitchFamily="34" charset="-122"/>
+                <a:cs typeface="Inter" pitchFamily="34" charset="-120"/>
+              </a:rPr>
+              <a:t>Every other PLC.</a:t>
+            </a:r>
+            <a:endParaRPr lang="en-US" sz="2200" dirty="0"/>
+          </a:p>
+          <a:p>
+            <a:pPr indent="0" marL="0">
+              <a:lnSpc>
+                <a:spcPct val="125000"/>
+              </a:lnSpc>
+              <a:buNone/>
+            </a:pPr>
+            <a:r>
+              <a:rPr lang="en-US" sz="2200" b="1" dirty="0">
+                <a:solidFill>
+                  <a:srgbClr val="13293D"/>
+                </a:solidFill>
+                <a:latin typeface="Inter" pitchFamily="34" charset="0"/>
+                <a:ea typeface="Inter" pitchFamily="34" charset="-122"/>
+                <a:cs typeface="Inter" pitchFamily="34" charset="-120"/>
+              </a:rPr>
+              <a:t>Five minutes: win · fail · steal.</a:t>
+            </a:r>
+            <a:endParaRPr lang="en-US" sz="2200" dirty="0"/>
+          </a:p>
+          <a:p>
+            <a:pPr indent="0" marL="0">
+              <a:lnSpc>
+                <a:spcPct val="125000"/>
+              </a:lnSpc>
+              <a:buNone/>
+            </a:pPr>
+            <a:r>
+              <a:rPr lang="en-US" sz="2200" b="1" dirty="0">
+                <a:solidFill>
+                  <a:srgbClr val="13293D"/>
+                </a:solidFill>
+                <a:latin typeface="Inter" pitchFamily="34" charset="0"/>
+                <a:ea typeface="Inter" pitchFamily="34" charset="-122"/>
+                <a:cs typeface="Inter" pitchFamily="34" charset="-120"/>
+              </a:rPr>
+              <a:t>Round one: Tuesday, hers.</a:t>
+            </a:r>
+            <a:endParaRPr lang="en-US" sz="2200" dirty="0"/>
           </a:p>
         </p:txBody>
       </p:sp>
@@ -12283,7 +12714,7 @@
                 <a:ea typeface="Inter" pitchFamily="34" charset="-122"/>
                 <a:cs typeface="Inter" pitchFamily="34" charset="-120"/>
               </a:rPr>
-              <a:t>Her onboarding + skeptic plan: Kit 1 for hires; skeptics recruited as reviewers.</a:t>
+              <a:t>Her culture page, step 3: a Kit 1 owner named; skeptics recruited as reviewers.</a:t>
             </a:r>
             <a:endParaRPr lang="en-US" sz="1000" dirty="0"/>
           </a:p>
@@ -12337,7 +12768,7 @@
         <p:spPr>
           <a:xfrm>
             <a:off x="548640" y="384048"/>
-            <a:ext cx="11091672" cy="777240"/>
+            <a:ext cx="7955280" cy="777240"/>
           </a:xfrm>
           <a:prstGeom prst="rect">
             <a:avLst/>
@@ -12376,11 +12807,11 @@
         <p:spPr>
           <a:xfrm>
             <a:off x="640080" y="1554480"/>
-            <a:ext cx="5394960" cy="3840480"/>
+            <a:ext cx="5394960" cy="1874520"/>
           </a:xfrm>
           <a:prstGeom prst="roundRect">
             <a:avLst>
-              <a:gd name="adj" fmla="val 2143"/>
+              <a:gd name="adj" fmla="val 4390"/>
             </a:avLst>
           </a:prstGeom>
           <a:solidFill>
@@ -12402,24 +12833,24 @@
         </p:nvSpPr>
         <p:spPr>
           <a:xfrm>
-            <a:off x="960120" y="1783080"/>
-            <a:ext cx="4800600" cy="365760"/>
-          </a:xfrm>
-          <a:prstGeom prst="rect">
-            <a:avLst/>
-          </a:prstGeom>
-          <a:noFill/>
-          <a:ln/>
-        </p:spPr>
-        <p:txBody>
-          <a:bodyPr wrap="square" lIns="0" tIns="0" rIns="0" bIns="0" rtlCol="0" anchor="ctr"/>
-          <a:lstStyle/>
-          <a:p>
-            <a:pPr indent="0" marL="0">
-              <a:buNone/>
-            </a:pPr>
-            <a:r>
-              <a:rPr lang="en-US" sz="1500" b="1" dirty="0">
+            <a:off x="960120" y="1719072"/>
+            <a:ext cx="4800600" cy="320040"/>
+          </a:xfrm>
+          <a:prstGeom prst="rect">
+            <a:avLst/>
+          </a:prstGeom>
+          <a:noFill/>
+          <a:ln/>
+        </p:spPr>
+        <p:txBody>
+          <a:bodyPr wrap="square" lIns="0" tIns="0" rIns="0" bIns="0" rtlCol="0" anchor="ctr"/>
+          <a:lstStyle/>
+          <a:p>
+            <a:pPr indent="0" marL="0">
+              <a:buNone/>
+            </a:pPr>
+            <a:r>
+              <a:rPr lang="en-US" sz="1400" b="1" dirty="0">
                 <a:solidFill>
                   <a:srgbClr val="2A9D8F"/>
                 </a:solidFill>
@@ -12429,7 +12860,7 @@
               </a:rPr>
               <a:t>ONBOARDING</a:t>
             </a:r>
-            <a:endParaRPr lang="en-US" sz="1500" dirty="0"/>
+            <a:endParaRPr lang="en-US" sz="1400" dirty="0"/>
           </a:p>
         </p:txBody>
       </p:sp>
@@ -12441,8 +12872,8 @@
         </p:nvSpPr>
         <p:spPr>
           <a:xfrm>
-            <a:off x="960120" y="2240280"/>
-            <a:ext cx="4800600" cy="2926080"/>
+            <a:off x="960120" y="2084832"/>
+            <a:ext cx="4800600" cy="1234440"/>
           </a:xfrm>
           <a:prstGeom prst="rect">
             <a:avLst/>
@@ -12458,7 +12889,7 @@
               <a:buNone/>
             </a:pPr>
             <a:r>
-              <a:rPr lang="en-US" sz="1700" dirty="0">
+              <a:rPr lang="en-US" sz="1600" dirty="0">
                 <a:solidFill>
                   <a:srgbClr val="1B1F24"/>
                 </a:solidFill>
@@ -12468,7 +12899,7 @@
               </a:rPr>
               <a:t>Who runs Kit 1 for new hires? What's in the welcome folder? (The norms page and a library tour, minimum.) Name the owner.</a:t>
             </a:r>
-            <a:endParaRPr lang="en-US" sz="1700" dirty="0"/>
+            <a:endParaRPr lang="en-US" sz="1600" dirty="0"/>
           </a:p>
         </p:txBody>
       </p:sp>
@@ -12480,12 +12911,12 @@
         </p:nvSpPr>
         <p:spPr>
           <a:xfrm>
-            <a:off x="6263640" y="1554480"/>
-            <a:ext cx="5394960" cy="3840480"/>
+            <a:off x="640080" y="3611880"/>
+            <a:ext cx="5394960" cy="1965960"/>
           </a:xfrm>
           <a:prstGeom prst="roundRect">
             <a:avLst>
-              <a:gd name="adj" fmla="val 2143"/>
+              <a:gd name="adj" fmla="val 4186"/>
             </a:avLst>
           </a:prstGeom>
           <a:solidFill>
@@ -12507,24 +12938,24 @@
         </p:nvSpPr>
         <p:spPr>
           <a:xfrm>
-            <a:off x="6583680" y="1783080"/>
-            <a:ext cx="4800600" cy="365760"/>
-          </a:xfrm>
-          <a:prstGeom prst="rect">
-            <a:avLst/>
-          </a:prstGeom>
-          <a:noFill/>
-          <a:ln/>
-        </p:spPr>
-        <p:txBody>
-          <a:bodyPr wrap="square" lIns="0" tIns="0" rIns="0" bIns="0" rtlCol="0" anchor="ctr"/>
-          <a:lstStyle/>
-          <a:p>
-            <a:pPr indent="0" marL="0">
-              <a:buNone/>
-            </a:pPr>
-            <a:r>
-              <a:rPr lang="en-US" sz="1500" b="1" dirty="0">
+            <a:off x="960120" y="3776472"/>
+            <a:ext cx="4800600" cy="320040"/>
+          </a:xfrm>
+          <a:prstGeom prst="rect">
+            <a:avLst/>
+          </a:prstGeom>
+          <a:noFill/>
+          <a:ln/>
+        </p:spPr>
+        <p:txBody>
+          <a:bodyPr wrap="square" lIns="0" tIns="0" rIns="0" bIns="0" rtlCol="0" anchor="ctr"/>
+          <a:lstStyle/>
+          <a:p>
+            <a:pPr indent="0" marL="0">
+              <a:buNone/>
+            </a:pPr>
+            <a:r>
+              <a:rPr lang="en-US" sz="1400" b="1" dirty="0">
                 <a:solidFill>
                   <a:srgbClr val="2A9D8F"/>
                 </a:solidFill>
@@ -12534,7 +12965,7 @@
               </a:rPr>
               <a:t>SKEPTIC PARTNERS</a:t>
             </a:r>
-            <a:endParaRPr lang="en-US" sz="1500" dirty="0"/>
+            <a:endParaRPr lang="en-US" sz="1400" dirty="0"/>
           </a:p>
         </p:txBody>
       </p:sp>
@@ -12546,8 +12977,8 @@
         </p:nvSpPr>
         <p:spPr>
           <a:xfrm>
-            <a:off x="6583680" y="2240280"/>
-            <a:ext cx="4800600" cy="2926080"/>
+            <a:off x="960120" y="4142232"/>
+            <a:ext cx="4800600" cy="1325880"/>
           </a:xfrm>
           <a:prstGeom prst="rect">
             <a:avLst/>
@@ -12563,7 +12994,7 @@
               <a:buNone/>
             </a:pPr>
             <a:r>
-              <a:rPr lang="en-US" sz="1700" dirty="0">
+              <a:rPr lang="en-US" sz="1600" dirty="0">
                 <a:solidFill>
                   <a:srgbClr val="1B1F24"/>
                 </a:solidFill>
@@ -12571,9 +13002,222 @@
                 <a:ea typeface="Inter" pitchFamily="34" charset="-122"/>
                 <a:cs typeface="Inter" pitchFamily="34" charset="-120"/>
               </a:rPr>
-              <a:t>Name the colleagues whose doubts keep us honest, and give them a real role: reviewers, drift-spotters, the first people we ask "what's wrong with this?" With respect, out loud.</a:t>
-            </a:r>
-            <a:endParaRPr lang="en-US" sz="1700" dirty="0"/>
+              <a:t>Name the colleagues whose doubts keep us honest, and give them a real role: reviewers, drift-spotters, the first people we ask "what's wrong with this?"</a:t>
+            </a:r>
+            <a:endParaRPr lang="en-US" sz="1600" dirty="0"/>
+          </a:p>
+        </p:txBody>
+      </p:sp>
+      <p:sp>
+        <p:nvSpPr>
+          <p:cNvPr id="20" name="Shape 17"/>
+          <p:cNvSpPr/>
+          <p:nvPr/>
+        </p:nvSpPr>
+        <p:spPr>
+          <a:xfrm>
+            <a:off x="6263640" y="1554480"/>
+            <a:ext cx="5394960" cy="4023360"/>
+          </a:xfrm>
+          <a:prstGeom prst="roundRect">
+            <a:avLst>
+              <a:gd name="adj" fmla="val 2045"/>
+            </a:avLst>
+          </a:prstGeom>
+          <a:solidFill>
+            <a:srgbClr val="EAF5F3"/>
+          </a:solidFill>
+          <a:ln w="12700">
+            <a:solidFill>
+              <a:srgbClr val="EAF5F3"/>
+            </a:solidFill>
+            <a:prstDash val="solid"/>
+          </a:ln>
+        </p:spPr>
+      </p:sp>
+      <p:sp>
+        <p:nvSpPr>
+          <p:cNvPr id="21" name="Text 18"/>
+          <p:cNvSpPr/>
+          <p:nvPr/>
+        </p:nvSpPr>
+        <p:spPr>
+          <a:xfrm>
+            <a:off x="6537960" y="1737360"/>
+            <a:ext cx="4937760" cy="292608"/>
+          </a:xfrm>
+          <a:prstGeom prst="rect">
+            <a:avLst/>
+          </a:prstGeom>
+          <a:noFill/>
+          <a:ln/>
+        </p:spPr>
+        <p:txBody>
+          <a:bodyPr wrap="square" lIns="0" tIns="0" rIns="0" bIns="0" rtlCol="0" anchor="ctr"/>
+          <a:lstStyle/>
+          <a:p>
+            <a:pPr indent="0" marL="0">
+              <a:buNone/>
+            </a:pPr>
+            <a:r>
+              <a:rPr lang="en-US" sz="1250" b="1" spc="150" kern="0" dirty="0">
+                <a:solidFill>
+                  <a:srgbClr val="2A9D8F"/>
+                </a:solidFill>
+                <a:latin typeface="Inter" pitchFamily="34" charset="0"/>
+                <a:ea typeface="Inter" pitchFamily="34" charset="-122"/>
+                <a:cs typeface="Inter" pitchFamily="34" charset="-120"/>
+              </a:rPr>
+              <a:t>MS. RIVERA'S CULTURE PAGE · STEP 3</a:t>
+            </a:r>
+            <a:endParaRPr lang="en-US" sz="1250" dirty="0"/>
+          </a:p>
+        </p:txBody>
+      </p:sp>
+      <p:sp>
+        <p:nvSpPr>
+          <p:cNvPr id="22" name="Text 19"/>
+          <p:cNvSpPr/>
+          <p:nvPr/>
+        </p:nvSpPr>
+        <p:spPr>
+          <a:xfrm>
+            <a:off x="6537960" y="2148840"/>
+            <a:ext cx="4892040" cy="3291840"/>
+          </a:xfrm>
+          <a:prstGeom prst="rect">
+            <a:avLst/>
+          </a:prstGeom>
+          <a:noFill/>
+          <a:ln/>
+        </p:spPr>
+        <p:txBody>
+          <a:bodyPr wrap="square" lIns="0" tIns="0" rIns="0" bIns="0" rtlCol="0" anchor="t"/>
+          <a:lstStyle/>
+          <a:p>
+            <a:pPr indent="0" marL="0">
+              <a:lnSpc>
+                <a:spcPct val="130000"/>
+              </a:lnSpc>
+              <a:buNone/>
+            </a:pPr>
+            <a:r>
+              <a:rPr lang="en-US" sz="1800" b="1" dirty="0">
+                <a:solidFill>
+                  <a:srgbClr val="13293D"/>
+                </a:solidFill>
+                <a:latin typeface="Inter" pitchFamily="34" charset="0"/>
+                <a:ea typeface="Inter" pitchFamily="34" charset="-122"/>
+                <a:cs typeface="Inter" pitchFamily="34" charset="-120"/>
+              </a:rPr>
+              <a:t>Kit 1 owner: </a:t>
+            </a:r>
+            <a:pPr indent="0" marL="0">
+              <a:lnSpc>
+                <a:spcPct val="130000"/>
+              </a:lnSpc>
+              <a:buNone/>
+            </a:pPr>
+            <a:r>
+              <a:rPr lang="en-US" sz="1800" dirty="0">
+                <a:solidFill>
+                  <a:srgbClr val="1B1F24"/>
+                </a:solidFill>
+                <a:latin typeface="Inter" pitchFamily="34" charset="0"/>
+                <a:ea typeface="Inter" pitchFamily="34" charset="-122"/>
+                <a:cs typeface="Inter" pitchFamily="34" charset="-120"/>
+              </a:rPr>
+              <a:t>her PLC lead, month one.
+</a:t>
+            </a:r>
+            <a:pPr indent="0" marL="0">
+              <a:lnSpc>
+                <a:spcPct val="130000"/>
+              </a:lnSpc>
+              <a:buNone/>
+            </a:pPr>
+            <a:r>
+              <a:rPr lang="en-US" sz="1800" b="1" dirty="0">
+                <a:solidFill>
+                  <a:srgbClr val="13293D"/>
+                </a:solidFill>
+                <a:latin typeface="Inter" pitchFamily="34" charset="0"/>
+                <a:ea typeface="Inter" pitchFamily="34" charset="-122"/>
+                <a:cs typeface="Inter" pitchFamily="34" charset="-120"/>
+              </a:rPr>
+              <a:t>Welcome folder: </a:t>
+            </a:r>
+            <a:pPr indent="0" marL="0">
+              <a:lnSpc>
+                <a:spcPct val="130000"/>
+              </a:lnSpc>
+              <a:buNone/>
+            </a:pPr>
+            <a:r>
+              <a:rPr lang="en-US" sz="1800" dirty="0">
+                <a:solidFill>
+                  <a:srgbClr val="1B1F24"/>
+                </a:solidFill>
+                <a:latin typeface="Inter" pitchFamily="34" charset="0"/>
+                <a:ea typeface="Inter" pitchFamily="34" charset="-122"/>
+                <a:cs typeface="Inter" pitchFamily="34" charset="-120"/>
+              </a:rPr>
+              <a:t>norms page + library tour.
+</a:t>
+            </a:r>
+            <a:pPr indent="0" marL="0">
+              <a:lnSpc>
+                <a:spcPct val="130000"/>
+              </a:lnSpc>
+              <a:buNone/>
+            </a:pPr>
+            <a:r>
+              <a:rPr lang="en-US" sz="1800" b="1" dirty="0">
+                <a:solidFill>
+                  <a:srgbClr val="13293D"/>
+                </a:solidFill>
+                <a:latin typeface="Inter" pitchFamily="34" charset="0"/>
+                <a:ea typeface="Inter" pitchFamily="34" charset="-122"/>
+                <a:cs typeface="Inter" pitchFamily="34" charset="-120"/>
+              </a:rPr>
+              <a:t>Skeptic partners: </a:t>
+            </a:r>
+            <a:pPr indent="0" marL="0">
+              <a:lnSpc>
+                <a:spcPct val="130000"/>
+              </a:lnSpc>
+              <a:buNone/>
+            </a:pPr>
+            <a:r>
+              <a:rPr lang="en-US" sz="1800" dirty="0">
+                <a:solidFill>
+                  <a:srgbClr val="1B1F24"/>
+                </a:solidFill>
+                <a:latin typeface="Inter" pitchFamily="34" charset="0"/>
+                <a:ea typeface="Inter" pitchFamily="34" charset="-122"/>
+                <a:cs typeface="Inter" pitchFamily="34" charset="-120"/>
+              </a:rPr>
+              <a:t>her two best doubters, recruited as reviewers of first resort.
+</a:t>
+            </a:r>
+            <a:pPr indent="0" marL="0">
+              <a:lnSpc>
+                <a:spcPct val="130000"/>
+              </a:lnSpc>
+              <a:buNone/>
+            </a:pPr>
+            <a:r>
+              <a:rPr lang="en-US" sz="1800" i="1" dirty="0">
+                <a:solidFill>
+                  <a:srgbClr val="5B6B7A"/>
+                </a:solidFill>
+                <a:latin typeface="Inter" pitchFamily="34" charset="0"/>
+                <a:ea typeface="Inter" pitchFamily="34" charset="-122"/>
+                <a:cs typeface="Inter" pitchFamily="34" charset="-120"/>
+              </a:rPr>
+              <a:t>"What's wrong with this?" goes to them first.</a:t>
+            </a:r>
+            <a:endParaRPr lang="en-US" sz="1800" dirty="0"/>
           </a:p>
         </p:txBody>
       </p:sp>
@@ -12926,7 +13570,7 @@
                 <a:ea typeface="Inter" pitchFamily="34" charset="-122"/>
                 <a:cs typeface="Inter" pitchFamily="34" charset="-120"/>
               </a:rPr>
-              <a:t>Her semester calendar: one refresher a month, norms revisited in January.</a:t>
+              <a:t>Her culture page, step 4: the semester strip, months and kit numbers written in.</a:t>
             </a:r>
             <a:endParaRPr lang="en-US" sz="1000" dirty="0"/>
           </a:p>
@@ -12980,7 +13624,7 @@
         <p:spPr>
           <a:xfrm>
             <a:off x="548640" y="384048"/>
-            <a:ext cx="11091672" cy="777240"/>
+            <a:ext cx="7955280" cy="777240"/>
           </a:xfrm>
           <a:prstGeom prst="rect">
             <a:avLst/>
@@ -13018,8 +13662,8 @@
         </p:nvSpPr>
         <p:spPr>
           <a:xfrm>
-            <a:off x="640080" y="1371600"/>
-            <a:ext cx="10908792" cy="4297680"/>
+            <a:off x="640080" y="1554480"/>
+            <a:ext cx="5394960" cy="4023360"/>
           </a:xfrm>
           <a:prstGeom prst="rect">
             <a:avLst/>
@@ -13039,7 +13683,7 @@
               <a:buChar char="•"/>
             </a:pPr>
             <a:r>
-              <a:rPr lang="en-US" sz="2100" dirty="0">
+              <a:rPr lang="en-US" sz="1600" dirty="0">
                 <a:solidFill>
                   <a:srgbClr val="1B1F24"/>
                 </a:solidFill>
@@ -13049,7 +13693,7 @@
               </a:rPr>
               <a:t>One 10-minute kit refresher a month, from the 30-day plans you already own</a:t>
             </a:r>
-            <a:endParaRPr lang="en-US" sz="2100" dirty="0"/>
+            <a:endParaRPr lang="en-US" sz="1600" dirty="0"/>
           </a:p>
           <a:p>
             <a:pPr marL="342900" indent="-342900">
@@ -13060,7 +13704,7 @@
               <a:buChar char="•"/>
             </a:pPr>
             <a:r>
-              <a:rPr lang="en-US" sz="2100" dirty="0">
+              <a:rPr lang="en-US" sz="1600" dirty="0">
                 <a:solidFill>
                   <a:srgbClr val="1B1F24"/>
                 </a:solidFill>
@@ -13070,7 +13714,7 @@
               </a:rPr>
               <a:t>Norms revisited in the first month back</a:t>
             </a:r>
-            <a:endParaRPr lang="en-US" sz="2100" dirty="0"/>
+            <a:endParaRPr lang="en-US" sz="1600" dirty="0"/>
           </a:p>
           <a:p>
             <a:pPr marL="342900" indent="-342900">
@@ -13081,7 +13725,7 @@
               <a:buChar char="•"/>
             </a:pPr>
             <a:r>
-              <a:rPr lang="en-US" sz="2100" dirty="0">
+              <a:rPr lang="en-US" sz="1600" dirty="0">
                 <a:solidFill>
                   <a:srgbClr val="1B1F24"/>
                 </a:solidFill>
@@ -13091,7 +13735,7 @@
               </a:rPr>
               <a:t>New-hire Kit 1 as needed</a:t>
             </a:r>
-            <a:endParaRPr lang="en-US" sz="2100" dirty="0"/>
+            <a:endParaRPr lang="en-US" sz="1600" dirty="0"/>
           </a:p>
           <a:p>
             <a:pPr marL="342900" indent="-342900">
@@ -13102,7 +13746,7 @@
               <a:buChar char="•"/>
             </a:pPr>
             <a:r>
-              <a:rPr lang="en-US" sz="2100" b="1" dirty="0">
+              <a:rPr lang="en-US" sz="1600" b="1" dirty="0">
                 <a:solidFill>
                   <a:srgbClr val="1B1F24"/>
                 </a:solidFill>
@@ -13112,7 +13756,234 @@
               </a:rPr>
               <a:t>Write the months and the kit numbers. That strip of calendar is what makes today permanent.</a:t>
             </a:r>
-            <a:endParaRPr lang="en-US" sz="2100" dirty="0"/>
+            <a:endParaRPr lang="en-US" sz="1600" dirty="0"/>
+          </a:p>
+        </p:txBody>
+      </p:sp>
+      <p:sp>
+        <p:nvSpPr>
+          <p:cNvPr id="15" name="Shape 12"/>
+          <p:cNvSpPr/>
+          <p:nvPr/>
+        </p:nvSpPr>
+        <p:spPr>
+          <a:xfrm>
+            <a:off x="6263640" y="1554480"/>
+            <a:ext cx="5394960" cy="4023360"/>
+          </a:xfrm>
+          <a:prstGeom prst="roundRect">
+            <a:avLst>
+              <a:gd name="adj" fmla="val 2045"/>
+            </a:avLst>
+          </a:prstGeom>
+          <a:solidFill>
+            <a:srgbClr val="EAF5F3"/>
+          </a:solidFill>
+          <a:ln w="12700">
+            <a:solidFill>
+              <a:srgbClr val="EAF5F3"/>
+            </a:solidFill>
+            <a:prstDash val="solid"/>
+          </a:ln>
+        </p:spPr>
+      </p:sp>
+      <p:sp>
+        <p:nvSpPr>
+          <p:cNvPr id="16" name="Text 13"/>
+          <p:cNvSpPr/>
+          <p:nvPr/>
+        </p:nvSpPr>
+        <p:spPr>
+          <a:xfrm>
+            <a:off x="6537960" y="1737360"/>
+            <a:ext cx="4937760" cy="292608"/>
+          </a:xfrm>
+          <a:prstGeom prst="rect">
+            <a:avLst/>
+          </a:prstGeom>
+          <a:noFill/>
+          <a:ln/>
+        </p:spPr>
+        <p:txBody>
+          <a:bodyPr wrap="square" lIns="0" tIns="0" rIns="0" bIns="0" rtlCol="0" anchor="ctr"/>
+          <a:lstStyle/>
+          <a:p>
+            <a:pPr indent="0" marL="0">
+              <a:buNone/>
+            </a:pPr>
+            <a:r>
+              <a:rPr lang="en-US" sz="1250" b="1" spc="150" kern="0" dirty="0">
+                <a:solidFill>
+                  <a:srgbClr val="2A9D8F"/>
+                </a:solidFill>
+                <a:latin typeface="Inter" pitchFamily="34" charset="0"/>
+                <a:ea typeface="Inter" pitchFamily="34" charset="-122"/>
+                <a:cs typeface="Inter" pitchFamily="34" charset="-120"/>
+              </a:rPr>
+              <a:t>MS. RIVERA'S CULTURE PAGE · STEP 4</a:t>
+            </a:r>
+            <a:endParaRPr lang="en-US" sz="1250" dirty="0"/>
+          </a:p>
+        </p:txBody>
+      </p:sp>
+      <p:sp>
+        <p:nvSpPr>
+          <p:cNvPr id="17" name="Text 14"/>
+          <p:cNvSpPr/>
+          <p:nvPr/>
+        </p:nvSpPr>
+        <p:spPr>
+          <a:xfrm>
+            <a:off x="6537960" y="2148840"/>
+            <a:ext cx="4892040" cy="2651760"/>
+          </a:xfrm>
+          <a:prstGeom prst="rect">
+            <a:avLst/>
+          </a:prstGeom>
+          <a:noFill/>
+          <a:ln/>
+        </p:spPr>
+        <p:txBody>
+          <a:bodyPr wrap="square" lIns="0" tIns="0" rIns="0" bIns="0" rtlCol="0" anchor="t"/>
+          <a:lstStyle/>
+          <a:p>
+            <a:pPr indent="0" marL="0">
+              <a:lnSpc>
+                <a:spcPct val="125000"/>
+              </a:lnSpc>
+              <a:buNone/>
+            </a:pPr>
+            <a:r>
+              <a:rPr lang="en-US" sz="2000" b="1" dirty="0">
+                <a:solidFill>
+                  <a:srgbClr val="13293D"/>
+                </a:solidFill>
+                <a:latin typeface="Inter" pitchFamily="34" charset="0"/>
+                <a:ea typeface="Inter" pitchFamily="34" charset="-122"/>
+                <a:cs typeface="Inter" pitchFamily="34" charset="-120"/>
+              </a:rPr>
+              <a:t>Jan · norms revisited</a:t>
+            </a:r>
+            <a:endParaRPr lang="en-US" sz="2000" dirty="0"/>
+          </a:p>
+          <a:p>
+            <a:pPr indent="0" marL="0">
+              <a:lnSpc>
+                <a:spcPct val="125000"/>
+              </a:lnSpc>
+              <a:buNone/>
+            </a:pPr>
+            <a:r>
+              <a:rPr lang="en-US" sz="2000" b="1" dirty="0">
+                <a:solidFill>
+                  <a:srgbClr val="13293D"/>
+                </a:solidFill>
+                <a:latin typeface="Inter" pitchFamily="34" charset="0"/>
+                <a:ea typeface="Inter" pitchFamily="34" charset="-122"/>
+                <a:cs typeface="Inter" pitchFamily="34" charset="-120"/>
+              </a:rPr>
+              <a:t>Feb · Kit 2 refresher</a:t>
+            </a:r>
+            <a:endParaRPr lang="en-US" sz="2000" dirty="0"/>
+          </a:p>
+          <a:p>
+            <a:pPr indent="0" marL="0">
+              <a:lnSpc>
+                <a:spcPct val="125000"/>
+              </a:lnSpc>
+              <a:buNone/>
+            </a:pPr>
+            <a:r>
+              <a:rPr lang="en-US" sz="2000" b="1" dirty="0">
+                <a:solidFill>
+                  <a:srgbClr val="13293D"/>
+                </a:solidFill>
+                <a:latin typeface="Inter" pitchFamily="34" charset="0"/>
+                <a:ea typeface="Inter" pitchFamily="34" charset="-122"/>
+                <a:cs typeface="Inter" pitchFamily="34" charset="-120"/>
+              </a:rPr>
+              <a:t>Mar · Kit 5 refresher</a:t>
+            </a:r>
+            <a:endParaRPr lang="en-US" sz="2000" dirty="0"/>
+          </a:p>
+          <a:p>
+            <a:pPr indent="0" marL="0">
+              <a:lnSpc>
+                <a:spcPct val="125000"/>
+              </a:lnSpc>
+              <a:buNone/>
+            </a:pPr>
+            <a:r>
+              <a:rPr lang="en-US" sz="2000" b="1" dirty="0">
+                <a:solidFill>
+                  <a:srgbClr val="13293D"/>
+                </a:solidFill>
+                <a:latin typeface="Inter" pitchFamily="34" charset="0"/>
+                <a:ea typeface="Inter" pitchFamily="34" charset="-122"/>
+                <a:cs typeface="Inter" pitchFamily="34" charset="-120"/>
+              </a:rPr>
+              <a:t>Apr · Kit 7 refresher</a:t>
+            </a:r>
+            <a:endParaRPr lang="en-US" sz="2000" dirty="0"/>
+          </a:p>
+          <a:p>
+            <a:pPr indent="0" marL="0">
+              <a:lnSpc>
+                <a:spcPct val="125000"/>
+              </a:lnSpc>
+              <a:buNone/>
+            </a:pPr>
+            <a:r>
+              <a:rPr lang="en-US" sz="2000" b="1" dirty="0">
+                <a:solidFill>
+                  <a:srgbClr val="13293D"/>
+                </a:solidFill>
+                <a:latin typeface="Inter" pitchFamily="34" charset="0"/>
+                <a:ea typeface="Inter" pitchFamily="34" charset="-122"/>
+                <a:cs typeface="Inter" pitchFamily="34" charset="-120"/>
+              </a:rPr>
+              <a:t>May · Kit 4 refresher</a:t>
+            </a:r>
+            <a:endParaRPr lang="en-US" sz="2000" dirty="0"/>
+          </a:p>
+        </p:txBody>
+      </p:sp>
+      <p:sp>
+        <p:nvSpPr>
+          <p:cNvPr id="18" name="Text 15"/>
+          <p:cNvSpPr/>
+          <p:nvPr/>
+        </p:nvSpPr>
+        <p:spPr>
+          <a:xfrm>
+            <a:off x="6537960" y="4983480"/>
+            <a:ext cx="4892040" cy="457200"/>
+          </a:xfrm>
+          <a:prstGeom prst="rect">
+            <a:avLst/>
+          </a:prstGeom>
+          <a:noFill/>
+          <a:ln/>
+        </p:spPr>
+        <p:txBody>
+          <a:bodyPr wrap="square" lIns="0" tIns="0" rIns="0" bIns="0" rtlCol="0" anchor="t"/>
+          <a:lstStyle/>
+          <a:p>
+            <a:pPr indent="0" marL="0">
+              <a:buNone/>
+            </a:pPr>
+            <a:r>
+              <a:rPr lang="en-US" sz="1600" i="1" dirty="0">
+                <a:solidFill>
+                  <a:srgbClr val="5B6B7A"/>
+                </a:solidFill>
+                <a:latin typeface="Inter" pitchFamily="34" charset="0"/>
+                <a:ea typeface="Inter" pitchFamily="34" charset="-122"/>
+                <a:cs typeface="Inter" pitchFamily="34" charset="-120"/>
+              </a:rPr>
+              <a:t>New-hire Kit 1, whenever the hire arrives.</a:t>
+            </a:r>
+            <a:endParaRPr lang="en-US" sz="1600" dirty="0"/>
           </a:p>
         </p:txBody>
       </p:sp>
@@ -13465,7 +14336,7 @@
                 <a:ea typeface="Inter" pitchFamily="34" charset="-122"/>
                 <a:cs typeface="Inter" pitchFamily="34" charset="-120"/>
               </a:rPr>
-              <a:t>Her share-out: one norm, read aloud.</a:t>
+              <a:t>Her share-out: her culture page's privacy norm, read aloud.</a:t>
             </a:r>
             <a:endParaRPr lang="en-US" sz="1000" dirty="0"/>
           </a:p>
@@ -13983,7 +14854,7 @@
                 <a:ea typeface="Inter" pitchFamily="34" charset="-122"/>
                 <a:cs typeface="Inter" pitchFamily="34" charset="-120"/>
               </a:rPr>
-              <a:t>Her inventory: norms, routine, onboarding plan, calendar. Culture, started.</a:t>
+              <a:t>Her inventory, one culture page: norms, routine, onboarding, semester strip.</a:t>
             </a:r>
             <a:endParaRPr lang="en-US" sz="1000" dirty="0"/>
           </a:p>

</xml_diff>

<commit_message>
Repoint Kit 8 and the site catalog at the rebuilt Kits 5 and 6
The Kit 5 rebuild deleted the lane framework, and Kit 8 told schools to
put lane labels on assignments and pointed at Kit 5 for them. Ten
references across its script, handout and deck now say what Kit 5
actually teaches: every assignment says what AI use is allowed.

The site catalog still sold Kit 6 as newsletters, difficult emails and
tone repair, with a lead objective of drafting faster, which is the
framing the rebuild deliberately replaced. Both catalog entries now
describe the sessions we actually ship.

Kit 8 deck and affected PDFs rebuilt, overlap clean, npm run build
passes.

Co-Authored-By: Claude Fable 5 <noreply@anthropic.com>
Claude-Session: https://claude.ai/code/session_019agQ42s1igQaB2X7GGat9R
</commit_message>
<xml_diff>
--- a/kits/kit08/Kit08_PresentationDeck.pptx
+++ b/kits/kit08/Kit08_PresentationDeck.pptx
@@ -8294,7 +8294,7 @@
                 <a:ea typeface="Inter" pitchFamily="34" charset="-122"/>
                 <a:cs typeface="Inter" pitchFamily="34" charset="-120"/>
               </a:rPr>
-              <a:t>The rules, the formula, the review habit, the lanes, the protected list: all of it transfers to whatever arrives next. That's the design.</a:t>
+              <a:t>The rules, the formula, the review habit, the one line on every assignment, the protected list: all of it transfers to whatever arrives next. That's the design.</a:t>
             </a:r>
             <a:endParaRPr lang="en-US" sz="2100" dirty="0"/>
           </a:p>
@@ -19544,7 +19544,7 @@
                 <a:ea typeface="Inter" pitchFamily="34" charset="-122"/>
                 <a:cs typeface="Inter" pitchFamily="34" charset="-120"/>
               </a:rPr>
-              <a:t>We say what we use. Every assignment carries its lane label, and a note home that started as a draft is still signed by the person who sends it.</a:t>
+              <a:t>We say what we use. Every assignment says what AI use is allowed, and a note home that started as a draft is still signed by the person who sends it.</a:t>
             </a:r>
             <a:endParaRPr lang="en-US" sz="1450" dirty="0"/>
           </a:p>
@@ -20820,7 +20820,7 @@
                 <a:ea typeface="Inter" pitchFamily="34" charset="-122"/>
                 <a:cs typeface="Inter" pitchFamily="34" charset="-120"/>
               </a:rPr>
-              <a:t>Kit 5 refresher, 10 minutes: lane labels</a:t>
+              <a:t>Kit 5 refresher, 10 minutes: the one thing AI cannot hand in</a:t>
             </a:r>
             <a:endParaRPr lang="en-US" sz="1350" dirty="0"/>
           </a:p>
@@ -28291,7 +28291,7 @@
                 <a:ea typeface="Inter" pitchFamily="34" charset="-122"/>
                 <a:cs typeface="Inter" pitchFamily="34" charset="-120"/>
               </a:rPr>
-              <a:t>They'd see: prompts shared openly · drafts reviewed before shipping · lanes labeled · no student names near a chatbot</a:t>
+              <a:t>They'd see: prompts shared openly · drafts reviewed before shipping · assignments saying what AI use is allowed · no student names near a chatbot</a:t>
             </a:r>
             <a:endParaRPr lang="en-US" sz="2000" dirty="0"/>
           </a:p>
@@ -29138,7 +29138,7 @@
                 <a:ea typeface="Inter" pitchFamily="34" charset="-122"/>
                 <a:cs typeface="Inter" pitchFamily="34" charset="-120"/>
               </a:rPr>
-              <a:t>We say what we use; assignments carry lane labels</a:t>
+              <a:t>We say what we use; every assignment says what AI use is allowed</a:t>
             </a:r>
             <a:endParaRPr lang="en-US" sz="1550" dirty="0"/>
           </a:p>

</xml_diff>

<commit_message>
Restore the previous Kit 5; revert its downstream repointing
Owner: "I actually like the previous kit 5 better than this new one."
My rebuild solved a problem that was not there. The real defect was
always deck design, which the new deck standard now addresses.

Kit 5 goes back to the version preceding the rebuild, with the
citation-audit corrections kept, so the lanes, the AI Box and the
Disclosure block return. Kit 8's lane references and the Kit 5 catalog
entry are restored to match. Kit 6 keeps its rebuild, which the owner
approved on its own terms, and its catalog entry stays on the new
thesis.

The rebuild remains in history and kits/kit05/REBUILD_SPEC.md is kept as
a record of the reasoning, including the AI Assessment Scale finding,
which still matters whatever version ships.

Co-Authored-By: Claude Fable 5 <noreply@anthropic.com>
Claude-Session: https://claude.ai/code/session_019agQ42s1igQaB2X7GGat9R
</commit_message>
<xml_diff>
--- a/kits/kit08/Kit08_PresentationDeck.pptx
+++ b/kits/kit08/Kit08_PresentationDeck.pptx
@@ -8294,7 +8294,7 @@
                 <a:ea typeface="Inter" pitchFamily="34" charset="-122"/>
                 <a:cs typeface="Inter" pitchFamily="34" charset="-120"/>
               </a:rPr>
-              <a:t>The rules, the formula, the review habit, the one line on every assignment, the protected list: all of it transfers to whatever arrives next. That's the design.</a:t>
+              <a:t>The rules, the formula, the review habit, the lanes, the protected list: all of it transfers to whatever arrives next. That's the design.</a:t>
             </a:r>
             <a:endParaRPr lang="en-US" sz="2100" dirty="0"/>
           </a:p>
@@ -19544,7 +19544,7 @@
                 <a:ea typeface="Inter" pitchFamily="34" charset="-122"/>
                 <a:cs typeface="Inter" pitchFamily="34" charset="-120"/>
               </a:rPr>
-              <a:t>We say what we use. Every assignment says what AI use is allowed, and a note home that started as a draft is still signed by the person who sends it.</a:t>
+              <a:t>We say what we use. Every assignment carries its lane label, and a note home that started as a draft is still signed by the person who sends it.</a:t>
             </a:r>
             <a:endParaRPr lang="en-US" sz="1450" dirty="0"/>
           </a:p>
@@ -20820,7 +20820,7 @@
                 <a:ea typeface="Inter" pitchFamily="34" charset="-122"/>
                 <a:cs typeface="Inter" pitchFamily="34" charset="-120"/>
               </a:rPr>
-              <a:t>Kit 5 refresher, 10 minutes: the one thing AI cannot hand in</a:t>
+              <a:t>Kit 5 refresher, 10 minutes: lane labels</a:t>
             </a:r>
             <a:endParaRPr lang="en-US" sz="1350" dirty="0"/>
           </a:p>
@@ -28291,7 +28291,7 @@
                 <a:ea typeface="Inter" pitchFamily="34" charset="-122"/>
                 <a:cs typeface="Inter" pitchFamily="34" charset="-120"/>
               </a:rPr>
-              <a:t>They'd see: prompts shared openly · drafts reviewed before shipping · assignments saying what AI use is allowed · no student names near a chatbot</a:t>
+              <a:t>They'd see: prompts shared openly · drafts reviewed before shipping · lanes labeled · no student names near a chatbot</a:t>
             </a:r>
             <a:endParaRPr lang="en-US" sz="2000" dirty="0"/>
           </a:p>
@@ -29138,7 +29138,7 @@
                 <a:ea typeface="Inter" pitchFamily="34" charset="-122"/>
                 <a:cs typeface="Inter" pitchFamily="34" charset="-120"/>
               </a:rPr>
-              <a:t>We say what we use; every assignment says what AI use is allowed</a:t>
+              <a:t>We say what we use; assignments carry lane labels</a:t>
             </a:r>
             <a:endParaRPr lang="en-US" sz="1550" dirty="0"/>
           </a:p>

</xml_diff>